<commit_message>
Fix team member name and remove Unit 3 note box from Tools slide
Corrects "Pradhanya S" -> "Pradhaniya S" in README and the presentation
deck (both PPTX and web version). Removes the amber "Forward link to
Unit 3" note box from the Tools slide per request.
</commit_message>
<xml_diff>
--- a/presentation/Krypsis_Presentation.pptx
+++ b/presentation/Krypsis_Presentation.pptx
@@ -3306,7 +3306,7 @@
                 </a:solidFill>
                 <a:latin typeface="Calibri"/>
               </a:rPr>
-              <a:t>Rithika K · CB.SC.U4AIE25126      Pradhanya S · CB.SC.U4AIE25148</a:t>
+              <a:t>Rithika K · CB.SC.U4AIE25126      Pradhaniya S · CB.SC.U4AIE25148</a:t>
             </a:r>
           </a:p>
           <a:p>
@@ -5062,171 +5062,6 @@
                 <a:latin typeface="Calibri"/>
               </a:rPr>
               <a:t>Version control, full project history</a:t>
-            </a:r>
-          </a:p>
-        </p:txBody>
-      </p:sp>
-      <p:sp>
-        <p:nvSpPr>
-          <p:cNvPr id="24" name="Rounded Rectangle 23"/>
-          <p:cNvSpPr/>
-          <p:nvPr/>
-        </p:nvSpPr>
-        <p:spPr>
-          <a:xfrm>
-            <a:off x="640080" y="4892040"/>
-            <a:ext cx="10881360" cy="1280160"/>
-          </a:xfrm>
-          <a:prstGeom prst="roundRect">
-            <a:avLst>
-              <a:gd name="adj" fmla="val 5000"/>
-            </a:avLst>
-          </a:prstGeom>
-          <a:solidFill>
-            <a:srgbClr val="F5E2C8"/>
-          </a:solidFill>
-          <a:ln w="12700">
-            <a:solidFill>
-              <a:srgbClr val="C97A2B"/>
-            </a:solidFill>
-          </a:ln>
-          <a:effectLst/>
-        </p:spPr>
-        <p:style>
-          <a:lnRef idx="1">
-            <a:schemeClr val="accent1"/>
-          </a:lnRef>
-          <a:fillRef idx="3">
-            <a:schemeClr val="accent1"/>
-          </a:fillRef>
-          <a:effectRef idx="2">
-            <a:schemeClr val="accent1"/>
-          </a:effectRef>
-          <a:fontRef idx="minor">
-            <a:schemeClr val="lt1"/>
-          </a:fontRef>
-        </p:style>
-        <p:txBody>
-          <a:bodyPr rtlCol="0" anchor="ctr"/>
-          <a:lstStyle/>
-          <a:p>
-            <a:pPr algn="ctr"/>
-          </a:p>
-        </p:txBody>
-      </p:sp>
-      <p:sp>
-        <p:nvSpPr>
-          <p:cNvPr id="25" name="TextBox 24"/>
-          <p:cNvSpPr txBox="1"/>
-          <p:nvPr/>
-        </p:nvSpPr>
-        <p:spPr>
-          <a:xfrm>
-            <a:off x="914400" y="5029200"/>
-            <a:ext cx="457200" cy="457200"/>
-          </a:xfrm>
-          <a:prstGeom prst="rect">
-            <a:avLst/>
-          </a:prstGeom>
-          <a:noFill/>
-        </p:spPr>
-        <p:txBody>
-          <a:bodyPr wrap="square" anchor="t">
-            <a:spAutoFit/>
-          </a:bodyPr>
-          <a:lstStyle/>
-          <a:p>
-            <a:pPr algn="l">
-              <a:lnSpc>
-                <a:spcPct val="115000"/>
-              </a:lnSpc>
-            </a:pPr>
-            <a:r>
-              <a:rPr sz="1200" b="1" i="0">
-                <a:solidFill>
-                  <a:srgbClr val="C97A2B"/>
-                </a:solidFill>
-                <a:latin typeface="Calibri"/>
-              </a:rPr>
-              <a:t>01</a:t>
-            </a:r>
-          </a:p>
-        </p:txBody>
-      </p:sp>
-      <p:sp>
-        <p:nvSpPr>
-          <p:cNvPr id="26" name="TextBox 25"/>
-          <p:cNvSpPr txBox="1"/>
-          <p:nvPr/>
-        </p:nvSpPr>
-        <p:spPr>
-          <a:xfrm>
-            <a:off x="914400" y="5029200"/>
-            <a:ext cx="10332720" cy="320040"/>
-          </a:xfrm>
-          <a:prstGeom prst="rect">
-            <a:avLst/>
-          </a:prstGeom>
-          <a:noFill/>
-        </p:spPr>
-        <p:txBody>
-          <a:bodyPr wrap="square" anchor="t">
-            <a:spAutoFit/>
-          </a:bodyPr>
-          <a:lstStyle/>
-          <a:p>
-            <a:pPr algn="l">
-              <a:lnSpc>
-                <a:spcPct val="115000"/>
-              </a:lnSpc>
-            </a:pPr>
-            <a:r>
-              <a:rPr sz="1200" b="1" i="0">
-                <a:solidFill>
-                  <a:srgbClr val="C97A2B"/>
-                </a:solidFill>
-                <a:latin typeface="Calibri"/>
-              </a:rPr>
-              <a:t>FORWARD LINK TO UNIT 3</a:t>
-            </a:r>
-          </a:p>
-        </p:txBody>
-      </p:sp>
-      <p:sp>
-        <p:nvSpPr>
-          <p:cNvPr id="27" name="TextBox 26"/>
-          <p:cNvSpPr txBox="1"/>
-          <p:nvPr/>
-        </p:nvSpPr>
-        <p:spPr>
-          <a:xfrm>
-            <a:off x="914400" y="5394960"/>
-            <a:ext cx="10332720" cy="685800"/>
-          </a:xfrm>
-          <a:prstGeom prst="rect">
-            <a:avLst/>
-          </a:prstGeom>
-          <a:noFill/>
-        </p:spPr>
-        <p:txBody>
-          <a:bodyPr wrap="square" anchor="t">
-            <a:spAutoFit/>
-          </a:bodyPr>
-          <a:lstStyle/>
-          <a:p>
-            <a:pPr algn="l">
-              <a:lnSpc>
-                <a:spcPct val="115000"/>
-              </a:lnSpc>
-            </a:pPr>
-            <a:r>
-              <a:rPr sz="1200" b="0" i="0">
-                <a:solidFill>
-                  <a:srgbClr val="172420"/>
-                </a:solidFill>
-                <a:latin typeface="Calibri"/>
-              </a:rPr>
-              <a:t>A natural next step is running the custom protocol over an actual simulated network topology in Mininet, using OpenFlow to control switch behavior — directly extending this project into the SDN material from Unit 3.</a:t>
             </a:r>
           </a:p>
         </p:txBody>

</xml_diff>

<commit_message>
Fix reproducibility: seed NumPy/Python too, not just TensorFlow
tf.random.set_seed() alone left ~1-3 point run-to-run accuracy
variance, since Keras's per-epoch data shuffling draws from NumPy's
RNG (not seeded) and CPU op parallelism is a separate source of
float non-determinism. Now seeds NumPy, Python's random module, and
TensorFlow, plus forces single-threaded ops -- verified by running
twice and getting byte-identical results.

This produces slightly different (and now genuinely reproducible)
numbers: centralized baseline 83.7% -> 83.25%, federated IID 80.4%
-> 80.24%, federated non-IID 79.0% -> 79.10%. All within half a
point of before -- updated everywhere these numbers appear:
README, PPTX, PDF handbook, and the web presentation deck.
</commit_message>
<xml_diff>
--- a/presentation/Krypsis_Presentation.pptx
+++ b/presentation/Krypsis_Presentation.pptx
@@ -6169,7 +6169,7 @@
                 </a:solidFill>
                 <a:latin typeface="Arial Black"/>
               </a:rPr>
-              <a:t>83.7%</a:t>
+              <a:t>83.3%</a:t>
             </a:r>
           </a:p>
         </p:txBody>
@@ -6295,7 +6295,7 @@
                 </a:solidFill>
                 <a:latin typeface="Arial Black"/>
               </a:rPr>
-              <a:t>80.4%</a:t>
+              <a:t>80.2%</a:t>
             </a:r>
           </a:p>
         </p:txBody>
@@ -6421,7 +6421,7 @@
                 </a:solidFill>
                 <a:latin typeface="Arial Black"/>
               </a:rPr>
-              <a:t>79.0%</a:t>
+              <a:t>79.1%</a:t>
             </a:r>
           </a:p>
         </p:txBody>

</xml_diff>